<commit_message>
Agrega referencias verificadas de la tesis en las notas del carrusel
Las notas de cada diapositiva citan las secciones del Trabajo Profesional
de Grado (2.a corrección) que respaldan el contenido. El texto visible no
cambia.

Co-Authored-By: Claude Opus 5.5 <noreply@anthropic.com>
Claude-Session: https://claude.ai/code/session_01MjAew2MHCwPQ64eTzCjtTQ
</commit_message>
<xml_diff>
--- a/impulso-empresarial/Impulso_Empresarial_LinkedIn.pptx
+++ b/impulso-empresarial/Impulso_Empresarial_LinkedIn.pptx
@@ -114,13 +114,13 @@
   <p:extLst>
     <p:ext uri="{521415D9-36F7-43E2-AB2F-B90AF26B5E84}">
       <p14:sectionLst xmlns:p14="http://schemas.microsoft.com/office/powerpoint/2010/main">
-        <p14:section name="Apertura" id="{416700e5-4500-13be-446e-e09debe1262a}">
+        <p14:section name="Apertura" id="{4bcc7d4c-0308-6f8a-b29f-a8e9d2edaa0b}">
           <p14:sldIdLst>
             <p14:sldId id="256"/>
             <p14:sldId id="257"/>
           </p14:sldIdLst>
         </p14:section>
-        <p14:section name="Propuesta" id="{73176758-6c8f-7519-e6c8-008345535949}">
+        <p14:section name="Propuesta" id="{49e5f024-5f0a-6ea7-43a0-e59dd4e8aaf6}">
           <p14:sldIdLst>
             <p14:sldId id="258"/>
             <p14:sldId id="259"/>
@@ -128,7 +128,7 @@
             <p14:sldId id="261"/>
           </p14:sldIdLst>
         </p14:section>
-        <p14:section name="Origen y cierre" id="{0fc3341d-b79e-cdd2-5602-600fbc2add39}">
+        <p14:section name="Origen y cierre" id="{bbcdce7d-8930-9784-e8ff-d13d05b18025}">
           <p14:sldIdLst>
             <p14:sldId id="262"/>
             <p14:sldId id="263"/>
@@ -812,7 +812,7 @@
           <a:p>
             <a:r>
               <a:rPr lang="en-US" dirty="0"/>
-              <a:t>Portada. Impulso Empresarial se presenta como una idea de negocio desarrollada en la tesis de Ingeniería Comercial de Derlis Javier Morinigo Ovelar; no como una empresa en operación. El diagrama resume la propuesta: datos de ventas, costos y caja integrados en información para tomar decisiones.</a:t>
+              <a:t>Portada. Impulso Empresarial se presenta como una idea de negocio desarrollada en la tesis de Ingeniería Comercial de Derlis Javier Morinigo Ovelar; no como una empresa en operación. El diagrama resume la propuesta: datos de ventas, costos y caja integrados en información para tomar decisiones. Referencia: Trabajo Profesional de Grado (2.ª corrección, 13-09): título de la obra y resumen ejecutivo. No se usa el título académico completo de la tesis.</a:t>
             </a:r>
             <a:endParaRPr lang="en-US" dirty="0"/>
           </a:p>
@@ -900,7 +900,7 @@
           <a:p>
             <a:r>
               <a:rPr lang="en-US" dirty="0"/>
-              <a:t>Las tres preguntas son situaciones habituales de gestión, no resultados de una encuesta ni estadísticas verificadas. Separan tres conceptos distintos: vender (ventas), ganar (rentabilidad: lo que queda después de costos y gastos) y cobrar (caja y liquidez). Un negocio puede vender más y aun así ganar menos, o ganar y no tener efectivo disponible.</a:t>
+              <a:t>Las tres preguntas son situaciones habituales de gestión, no resultados de una encuesta ni estadísticas verificadas. Separan tres conceptos distintos: vender (ventas), ganar (rentabilidad: lo que queda después de costos y gastos) y cobrar (caja y liquidez). Un negocio puede vender más y aun así ganar menos, o ganar y no tener efectivo disponible. Referencia: Trabajo Profesional de Grado (2.ª corrección, 13-09), 2.2.1: aplicaciones al seguimiento de ventas, costos y gastos, a la rentabilidad por producto o cliente y al control de inventarios y cobranzas. La pregunta de caja (efectivo de las próximas semanas) va un paso más allá del alcance escrito en la tesis, que menciona cobranzas pero no proyección de caja.</a:t>
             </a:r>
             <a:endParaRPr lang="en-US" dirty="0"/>
           </a:p>
@@ -988,7 +988,7 @@
           <a:p>
             <a:r>
               <a:rPr lang="en-US" dirty="0"/>
-              <a:t>Propuesta de consultoría unipersonal en Inteligencia de Negocios (Business Intelligence, BI) para micro, pequeñas y medianas empresas. «Ordenar, visualizar, decidir» es una síntesis comercial para este carrusel. Foco inicial: San Lorenzo y el área metropolitana de Paraguay. Es una idea de negocio de la tesis: no se afirma que esté operando ni que tenga clientes.</a:t>
+              <a:t>Propuesta de consultoría unipersonal en Inteligencia de Negocios (Business Intelligence, BI) para micro, pequeñas y medianas empresas. «Ordenar, visualizar, decidir» es una síntesis comercial para este carrusel. Foco inicial: San Lorenzo y el área metropolitana de Paraguay. Es una idea de negocio de la tesis: no se afirma que esté operando ni que tenga clientes. Referencia: Trabajo Profesional de Grado (2.ª corrección, 13-09): resumen ejecutivo; 2.1 y Tabla 1 (consultora unipersonal, MIPYMES, San Lorenzo y área metropolitana, atención presencial y virtual); 2.2.2 (mercado de referencia).</a:t>
             </a:r>
             <a:endParaRPr lang="en-US" dirty="0"/>
           </a:p>
@@ -1076,7 +1076,7 @@
           <a:p>
             <a:r>
               <a:rPr lang="en-US" dirty="0"/>
-              <a:t>Alcance propuesto del servicio: diagnóstico de información y necesidades, tableros de control, automatización de reportes, definición y análisis de indicadores, capacitación y acompañamiento posterior. Herramientas: Excel y Power BI. Lenguaje de propuesta: no se publican precios, paquetes comerciales ni compromisos contractuales.</a:t>
+              <a:t>Alcance propuesto del servicio: diagnóstico de información y necesidades, tableros de control, automatización de reportes, definición y análisis de indicadores, capacitación y acompañamiento posterior. Herramientas: Excel y Power BI. Lenguaje de propuesta: no se publican precios, paquetes comerciales ni compromisos contractuales. Referencia: Trabajo Profesional de Grado (2.ª corrección, 13-09): resumen ejecutivo (diagnóstico, tableros, automatización de reportes, análisis de indicadores, mantenimiento mensual); 2.2.1 (capacitación inicial; mantenimiento y soporte mensual); Tabla 2 (integración de planillas Excel); 2.8.1 (Power BI). Los niveles básico, estándar y avanzado y los precios de la Tabla 10 se omiten a propósito.</a:t>
             </a:r>
             <a:endParaRPr lang="en-US" dirty="0"/>
           </a:p>
@@ -1175,7 +1175,8 @@
 Margen bruto: antes de gastos operativos, intereses e impuestos. No es utilidad neta.
 Cuentas por cobrar al cierre: Gs. 45 millones. Es un saldo adicional simulado; no son cobros del mes ni flujo de caja, ni una parte adicional de las ventas que deba sumarse a los Gs. 120 millones.
 Lectura: la Línea B tiene la mitad del margen de A y C. El tablero no da la respuesta; indica dónde revisar (precios, costos o descuentos) antes de decidir.
-El gráfico es nativo de PowerPoint: los datos se editan con clic derecho &gt; Editar datos.</a:t>
+El gráfico es nativo de PowerPoint: los datos se editan con clic derecho &gt; Editar datos.
+Referencia: Trabajo Profesional de Grado (2.ª corrección, 13-09), 2.2.1: «un tablero comercial podrá mostrar la evolución de las ventas y los márgenes por producto». Los importes del ejemplo no provienen de la tesis.</a:t>
             </a:r>
             <a:endParaRPr lang="en-US" dirty="0"/>
           </a:p>
@@ -1263,7 +1264,7 @@
           <a:p>
             <a:r>
               <a:rPr lang="en-US" dirty="0"/>
-              <a:t>Proceso propuesto en cuatro pasos: entender las decisiones, ordenar y validar los datos, implementar tablero y reportes según el alcance acordado, y acompañar el uso de los indicadores. Modalidad: implementación por proyecto más seguimiento mensual. No se fijan plazos, cantidad de reuniones ni compromisos contractuales.</a:t>
+              <a:t>Proceso propuesto en cuatro pasos: entender las decisiones, ordenar y validar los datos, implementar tablero y reportes según el alcance acordado, y acompañar el uso de los indicadores. Modalidad: implementación por proyecto más seguimiento mensual. No se fijan plazos, cantidad de reuniones ni compromisos contractuales. Referencia: Trabajo Profesional de Grado (2.ª corrección, 13-09): 7.4, Tablas 24, 25 y 27 (diagnóstico y propuesta, ejecución del servicio, seguimiento posventa) y 2.2.1 (implementación por proyecto; mantenimiento como prestación recurrente). En la tesis la prestación mensual se denomina «mantenimiento y soporte»; «seguimiento mensual» es la forma simplificada usada en el carrusel.</a:t>
             </a:r>
             <a:endParaRPr lang="en-US" dirty="0"/>
           </a:p>
@@ -1351,7 +1352,7 @@
           <a:p>
             <a:r>
               <a:rPr lang="en-US" dirty="0"/>
-              <a:t>Contexto profesional del autor, sin convertir la página en un currículum. Impulso Empresarial se desarrolló como proyecto de tesis de Ingeniería Comercial; no se usa el título de Ingeniero Comercial ni se afirma que la tesis ya fue defendida. No se menciona al empleador actual ni logros comerciales de Impulso Empresarial.</a:t>
+              <a:t>Contexto profesional del autor, sin convertir la página en un currículum. Impulso Empresarial se desarrolló como proyecto de tesis de Ingeniería Comercial; no se usa el título de Ingeniero Comercial ni se afirma que la tesis ya fue defendida. No se menciona al empleador actual ni logros comerciales de Impulso Empresarial. Referencia: Trabajo Profesional de Grado (2.ª corrección, 13-09): portada (autor y carrera) y 4.8 (la experiencia profesional del consultor como parte de la ventaja competitiva).</a:t>
             </a:r>
             <a:endParaRPr lang="en-US" dirty="0"/>
           </a:p>
@@ -1439,7 +1440,7 @@
           <a:p>
             <a:r>
               <a:rPr lang="en-US" dirty="0"/>
-              <a:t>Invitación a conversar para seguir afinando la propuesta y a visitar el perfil de LinkedIn. No se agregan teléfono, correo, QR, enlaces ni ofertas (por ejemplo, diagnósticos gratuitos).</a:t>
+              <a:t>Invitación a conversar para seguir afinando la propuesta y a visitar el perfil de LinkedIn. No se agregan teléfono, correo, QR, enlaces ni ofertas (por ejemplo, diagnósticos gratuitos). Referencia: Trabajo Profesional de Grado (2.ª corrección, 13-09): 2.8.1 prevé LinkedIn como canal de contacto; el resumen ejecutivo indica que la captación y la disposición de pago deben validarse antes de implementar. Las conversaciones que genere el carrusel son señales cualitativas, no una validación de mercado.</a:t>
             </a:r>
             <a:endParaRPr lang="en-US" dirty="0"/>
           </a:p>

</xml_diff>